<commit_message>
Troca a instituição para FAETEC de Quintino
Co-Authored-By: Claude Opus 5.5 (1M context) <noreply@anthropic.com>
Claude-Session: https://claude.ai/code/session_01FEMtm3REE4Du1LXrG82jym
</commit_message>
<xml_diff>
--- a/docs/entrega/Apresentacao_ACSO_Arthur_Pravato.pptx
+++ b/docs/entrega/Apresentacao_ACSO_Arthur_Pravato.pptx
@@ -120,18 +120,18 @@
   <p:extLst>
     <p:ext uri="{521415D9-36F7-43E2-AB2F-B90AF26B5E84}">
       <p14:sectionLst xmlns:p14="http://schemas.microsoft.com/office/powerpoint/2010/main">
-        <p14:section name="Abertura" id="{563ec36c-d797-639c-f9a8-6a548fb30d7f}">
+        <p14:section name="Abertura" id="{f4f3700f-dbea-fb6c-7750-9a968f4837e8}">
           <p14:sldIdLst>
             <p14:sldId id="256"/>
           </p14:sldIdLst>
         </p14:section>
-        <p14:section name="Problema" id="{a635df60-7bbd-7eb6-e704-d29fbc516cc2}">
+        <p14:section name="Problema" id="{3b045d2e-b03b-4cef-97da-e68598394104}">
           <p14:sldIdLst>
             <p14:sldId id="257"/>
             <p14:sldId id="258"/>
           </p14:sldIdLst>
         </p14:section>
-        <p14:section name="Solução" id="{a5db0a3e-1cb1-4253-097c-0f78b26089c3}">
+        <p14:section name="Solução" id="{c5ae0975-99de-fc3a-19ba-45955583d8eb}">
           <p14:sldIdLst>
             <p14:sldId id="259"/>
             <p14:sldId id="260"/>
@@ -139,25 +139,25 @@
             <p14:sldId id="262"/>
           </p14:sldIdLst>
         </p14:section>
-        <p14:section name="Engenharia de prompt" id="{4e11f28c-64b8-15f5-62c2-185fd6623cf2}">
+        <p14:section name="Engenharia de prompt" id="{78ca11f6-a2ae-9c77-5c6b-c889fdd4374d}">
           <p14:sldIdLst>
             <p14:sldId id="263"/>
             <p14:sldId id="264"/>
           </p14:sldIdLst>
         </p14:section>
-        <p14:section name="Funcionando" id="{aaf23be6-d13a-8067-e857-58534c4f9e65}">
+        <p14:section name="Funcionando" id="{0d4af0f5-bf11-40a6-b1b7-40ae1f4e944c}">
           <p14:sldIdLst>
             <p14:sldId id="265"/>
             <p14:sldId id="266"/>
           </p14:sldIdLst>
         </p14:section>
-        <p14:section name="Avaliação" id="{928cc843-cdb6-34a0-7ab1-7f9f1ed65ddd}">
+        <p14:section name="Avaliação" id="{657ccf99-b3ea-55da-f0ee-6d59925c8159}">
           <p14:sldIdLst>
             <p14:sldId id="267"/>
             <p14:sldId id="268"/>
           </p14:sldIdLst>
         </p14:section>
-        <p14:section name="Conclusão" id="{f94aecbd-2d6c-e08d-b9f9-ae753368a1c1}">
+        <p14:section name="Conclusão" id="{18f30ea9-510e-cf70-ba9c-f5563e5ea8bd}">
           <p14:sldIdLst>
             <p14:sldId id="269"/>
           </p14:sldIdLst>
@@ -2841,7 +2841,7 @@
                   <a:schemeClr val="bg1"/>
                 </a:solidFill>
               </a:rPr>
-              <a:t>Centro Universitário São José / FAETEC · 24/10/2026</a:t>
+              <a:t>FAETEC de Quintino · 24/10/2026</a:t>
             </a:r>
             <a:endParaRPr lang="en-US" sz="1200" dirty="0"/>
           </a:p>

</xml_diff>

<commit_message>
Ajusta curso e nome da disciplina
Co-Authored-By: Claude Opus 5.5 (1M context) <noreply@anthropic.com>
Claude-Session: https://claude.ai/code/session_01FEMtm3REE4Du1LXrG82jym
</commit_message>
<xml_diff>
--- a/docs/entrega/Apresentacao_ACSO_Arthur_Pravato.pptx
+++ b/docs/entrega/Apresentacao_ACSO_Arthur_Pravato.pptx
@@ -120,18 +120,18 @@
   <p:extLst>
     <p:ext uri="{521415D9-36F7-43E2-AB2F-B90AF26B5E84}">
       <p14:sectionLst xmlns:p14="http://schemas.microsoft.com/office/powerpoint/2010/main">
-        <p14:section name="Abertura" id="{f4f3700f-dbea-fb6c-7750-9a968f4837e8}">
+        <p14:section name="Abertura" id="{ec0f3f13-310d-c3a9-e837-26cc72bfbc2d}">
           <p14:sldIdLst>
             <p14:sldId id="256"/>
           </p14:sldIdLst>
         </p14:section>
-        <p14:section name="Problema" id="{3b045d2e-b03b-4cef-97da-e68598394104}">
+        <p14:section name="Problema" id="{5cc7f1e6-7157-09e2-f220-e96f69e3b969}">
           <p14:sldIdLst>
             <p14:sldId id="257"/>
             <p14:sldId id="258"/>
           </p14:sldIdLst>
         </p14:section>
-        <p14:section name="Solução" id="{c5ae0975-99de-fc3a-19ba-45955583d8eb}">
+        <p14:section name="Solução" id="{b56834ea-92a5-c156-a5fe-2d3e60cf1a4a}">
           <p14:sldIdLst>
             <p14:sldId id="259"/>
             <p14:sldId id="260"/>
@@ -139,25 +139,25 @@
             <p14:sldId id="262"/>
           </p14:sldIdLst>
         </p14:section>
-        <p14:section name="Engenharia de prompt" id="{78ca11f6-a2ae-9c77-5c6b-c889fdd4374d}">
+        <p14:section name="Engenharia de prompt" id="{105babec-7bc2-039e-5e79-2fe00b5e2f92}">
           <p14:sldIdLst>
             <p14:sldId id="263"/>
             <p14:sldId id="264"/>
           </p14:sldIdLst>
         </p14:section>
-        <p14:section name="Funcionando" id="{0d4af0f5-bf11-40a6-b1b7-40ae1f4e944c}">
+        <p14:section name="Funcionando" id="{1538bd38-335c-d761-2602-7f18ecfa12fc}">
           <p14:sldIdLst>
             <p14:sldId id="265"/>
             <p14:sldId id="266"/>
           </p14:sldIdLst>
         </p14:section>
-        <p14:section name="Avaliação" id="{657ccf99-b3ea-55da-f0ee-6d59925c8159}">
+        <p14:section name="Avaliação" id="{132fee6d-faf8-a213-2dff-ae2f5b384061}">
           <p14:sldIdLst>
             <p14:sldId id="267"/>
             <p14:sldId id="268"/>
           </p14:sldIdLst>
         </p14:section>
-        <p14:section name="Conclusão" id="{18f30ea9-510e-cf70-ba9c-f5563e5ea8bd}">
+        <p14:section name="Conclusão" id="{4e8ca780-edf4-7b36-a3f3-7364ee8511c0}">
           <p14:sldIdLst>
             <p14:sldId id="269"/>
           </p14:sldIdLst>
@@ -2681,7 +2681,7 @@
         <p:spPr>
           <a:xfrm>
             <a:off x="548640" y="640080"/>
-            <a:ext cx="5486400" cy="320040"/>
+            <a:ext cx="8046720" cy="320040"/>
           </a:xfrm>
           <a:prstGeom prst="rect">
             <a:avLst/>
@@ -2697,14 +2697,14 @@
               <a:buNone/>
             </a:pPr>
             <a:r>
-              <a:rPr lang="en-US" sz="1200" b="1" spc="300" kern="0" dirty="0">
+              <a:rPr lang="en-US" sz="1100" b="1" spc="300" kern="0" dirty="0">
                 <a:solidFill>
                   <a:schemeClr val="accent5"/>
                 </a:solidFill>
               </a:rPr>
-              <a:t>ACSO – SISTEMAS AUTÔNOMOS</a:t>
-            </a:r>
-            <a:endParaRPr lang="en-US" sz="1200" dirty="0"/>
+              <a:t>ACSO – ARQUITETURA E COMPUTAÇÃO DE SISTEMAS OPERACIONAIS</a:t>
+            </a:r>
+            <a:endParaRPr lang="en-US" sz="1100" dirty="0"/>
           </a:p>
         </p:txBody>
       </p:sp>
@@ -2827,7 +2827,7 @@
                   <a:schemeClr val="bg1"/>
                 </a:solidFill>
               </a:rPr>
-              <a:t>Turma 1212 · Prof. Gilberto Gomes</a:t>
+              <a:t>Técnico em Informática · Turma 1212 · Prof. Gilberto Gomes</a:t>
             </a:r>
             <a:endParaRPr lang="en-US" sz="1200" dirty="0"/>
           </a:p>

</xml_diff>

<commit_message>
Corrige erro de digitação no print da conversa
Co-Authored-By: Claude Opus 5.5 (1M context) <noreply@anthropic.com>
Claude-Session: https://claude.ai/code/session_01FEMtm3REE4Du1LXrG82jym
</commit_message>
<xml_diff>
--- a/docs/entrega/Apresentacao_ACSO_Arthur_Pravato.pptx
+++ b/docs/entrega/Apresentacao_ACSO_Arthur_Pravato.pptx
@@ -120,18 +120,18 @@
   <p:extLst>
     <p:ext uri="{521415D9-36F7-43E2-AB2F-B90AF26B5E84}">
       <p14:sectionLst xmlns:p14="http://schemas.microsoft.com/office/powerpoint/2010/main">
-        <p14:section name="Abertura" id="{ec0f3f13-310d-c3a9-e837-26cc72bfbc2d}">
+        <p14:section name="Abertura" id="{8156e97f-2252-95e2-7abe-d691cf7b0e37}">
           <p14:sldIdLst>
             <p14:sldId id="256"/>
           </p14:sldIdLst>
         </p14:section>
-        <p14:section name="Problema" id="{5cc7f1e6-7157-09e2-f220-e96f69e3b969}">
+        <p14:section name="Problema" id="{9dfc8f78-e35e-c112-e226-bf391d2e9cb4}">
           <p14:sldIdLst>
             <p14:sldId id="257"/>
             <p14:sldId id="258"/>
           </p14:sldIdLst>
         </p14:section>
-        <p14:section name="Solução" id="{b56834ea-92a5-c156-a5fe-2d3e60cf1a4a}">
+        <p14:section name="Solução" id="{8e620a73-35ff-e826-9984-bc9abebeffea}">
           <p14:sldIdLst>
             <p14:sldId id="259"/>
             <p14:sldId id="260"/>
@@ -139,25 +139,25 @@
             <p14:sldId id="262"/>
           </p14:sldIdLst>
         </p14:section>
-        <p14:section name="Engenharia de prompt" id="{105babec-7bc2-039e-5e79-2fe00b5e2f92}">
+        <p14:section name="Engenharia de prompt" id="{84d3e309-c508-07ae-5c58-e1d75c0604e7}">
           <p14:sldIdLst>
             <p14:sldId id="263"/>
             <p14:sldId id="264"/>
           </p14:sldIdLst>
         </p14:section>
-        <p14:section name="Funcionando" id="{1538bd38-335c-d761-2602-7f18ecfa12fc}">
+        <p14:section name="Funcionando" id="{19a549ba-7184-d402-ca34-aeae6132b6e5}">
           <p14:sldIdLst>
             <p14:sldId id="265"/>
             <p14:sldId id="266"/>
           </p14:sldIdLst>
         </p14:section>
-        <p14:section name="Avaliação" id="{132fee6d-faf8-a213-2dff-ae2f5b384061}">
+        <p14:section name="Avaliação" id="{21d60756-81ac-d913-8868-7c44d476ded6}">
           <p14:sldIdLst>
             <p14:sldId id="267"/>
             <p14:sldId id="268"/>
           </p14:sldIdLst>
         </p14:section>
-        <p14:section name="Conclusão" id="{4e8ca780-edf4-7b36-a3f3-7364ee8511c0}">
+        <p14:section name="Conclusão" id="{9c9ac8d8-20f7-c3c2-bc50-ea80c52dd7f9}">
           <p14:sldIdLst>
             <p14:sldId id="269"/>
           </p14:sldIdLst>

</xml_diff>

<commit_message>
Adiciona a integração com o WhatsApp ao relatório, ao Word e à apresentação
Co-Authored-By: Claude Opus 5.5 (1M context) <noreply@anthropic.com>
Claude-Session: https://claude.ai/code/session_01FEMtm3REE4Du1LXrG82jym
</commit_message>
<xml_diff>
--- a/docs/entrega/Apresentacao_ACSO_Arthur_Pravato.pptx
+++ b/docs/entrega/Apresentacao_ACSO_Arthur_Pravato.pptx
@@ -19,9 +19,10 @@
     <p:sldId id="267" r:id="rId13"/>
     <p:sldId id="268" r:id="rId14"/>
     <p:sldId id="269" r:id="rId15"/>
+    <p:sldId id="270" r:id="rId16"/>
   </p:sldIdLst>
   <p:notesMasterIdLst>
-    <p:notesMasterId r:id="rId16"/>
+    <p:notesMasterId r:id="rId17"/>
   </p:notesMasterIdLst>
   <p:sldSz cx="9144000" cy="5143500"/>
   <p:notesSz cx="5143500" cy="9144000"/>
@@ -120,18 +121,18 @@
   <p:extLst>
     <p:ext uri="{521415D9-36F7-43E2-AB2F-B90AF26B5E84}">
       <p14:sectionLst xmlns:p14="http://schemas.microsoft.com/office/powerpoint/2010/main">
-        <p14:section name="Abertura" id="{8156e97f-2252-95e2-7abe-d691cf7b0e37}">
+        <p14:section name="Abertura" id="{09709502-0e45-c682-47fb-6d9c41246283}">
           <p14:sldIdLst>
             <p14:sldId id="256"/>
           </p14:sldIdLst>
         </p14:section>
-        <p14:section name="Problema" id="{9dfc8f78-e35e-c112-e226-bf391d2e9cb4}">
+        <p14:section name="Problema" id="{6bde8466-6ab3-6faf-55f2-176f23351527}">
           <p14:sldIdLst>
             <p14:sldId id="257"/>
             <p14:sldId id="258"/>
           </p14:sldIdLst>
         </p14:section>
-        <p14:section name="Solução" id="{8e620a73-35ff-e826-9984-bc9abebeffea}">
+        <p14:section name="Solução" id="{3fcf53a9-27e5-b855-712c-7260f05a5162}">
           <p14:sldIdLst>
             <p14:sldId id="259"/>
             <p14:sldId id="260"/>
@@ -139,27 +140,28 @@
             <p14:sldId id="262"/>
           </p14:sldIdLst>
         </p14:section>
-        <p14:section name="Engenharia de prompt" id="{84d3e309-c508-07ae-5c58-e1d75c0604e7}">
+        <p14:section name="Engenharia de prompt" id="{cfd692b5-a195-6724-cde9-c39cc7b39660}">
           <p14:sldIdLst>
             <p14:sldId id="263"/>
             <p14:sldId id="264"/>
           </p14:sldIdLst>
         </p14:section>
-        <p14:section name="Funcionando" id="{19a549ba-7184-d402-ca34-aeae6132b6e5}">
+        <p14:section name="Funcionando" id="{2545fa36-6e1f-d29b-10cd-19624fe3734d}">
           <p14:sldIdLst>
             <p14:sldId id="265"/>
             <p14:sldId id="266"/>
+            <p14:sldId id="267"/>
           </p14:sldIdLst>
         </p14:section>
-        <p14:section name="Avaliação" id="{21d60756-81ac-d913-8868-7c44d476ded6}">
+        <p14:section name="Avaliação" id="{281c4483-efec-8169-0502-71779c4d9bd4}">
           <p14:sldIdLst>
-            <p14:sldId id="267"/>
             <p14:sldId id="268"/>
+            <p14:sldId id="269"/>
           </p14:sldIdLst>
         </p14:section>
-        <p14:section name="Conclusão" id="{9c9ac8d8-20f7-c3c2-bc50-ea80c52dd7f9}">
+        <p14:section name="Conclusão" id="{4e648f56-205c-b44d-3297-f0dbe1ea794c}">
           <p14:sldIdLst>
-            <p14:sldId id="269"/>
+            <p14:sldId id="270"/>
           </p14:sldIdLst>
         </p14:section>
       </p14:sectionLst>
@@ -1370,6 +1372,94 @@
             <a:fld id="{F7021451-1387-4CA6-816F-3879F97B5CBC}" type="slidenum">
               <a:rPr lang="en-US"/>
               <a:t>14</a:t>
+            </a:fld>
+            <a:endParaRPr lang="en-US"/>
+          </a:p>
+        </p:txBody>
+      </p:sp>
+    </p:spTree>
+    <p:extLst>
+      <p:ext uri="{BB962C8B-B14F-4D97-AF65-F5344CB8AC3E}">
+        <p14:creationId xmlns:p14="http://schemas.microsoft.com/office/powerpoint/2010/main" val="1024086991"/>
+      </p:ext>
+    </p:extLst>
+  </p:cSld>
+  <p:clrMapOvr>
+    <a:masterClrMapping/>
+  </p:clrMapOvr>
+</p:notes>
+</file>
+
+<file path=ppt/notesSlides/notesSlide15.xml><?xml version="1.0" encoding="utf-8"?>
+<p:notes xmlns:a="http://schemas.openxmlformats.org/drawingml/2006/main" xmlns:r="http://schemas.openxmlformats.org/officeDocument/2006/relationships" xmlns:p="http://schemas.openxmlformats.org/presentationml/2006/main">
+  <p:cSld>
+    <p:spTree>
+      <p:nvGrpSpPr>
+        <p:cNvPr id="1" name=""/>
+        <p:cNvGrpSpPr/>
+        <p:nvPr/>
+      </p:nvGrpSpPr>
+      <p:grpSpPr>
+        <a:xfrm>
+          <a:off x="0" y="0"/>
+          <a:ext cx="0" cy="0"/>
+          <a:chOff x="0" y="0"/>
+          <a:chExt cx="0" cy="0"/>
+        </a:xfrm>
+      </p:grpSpPr>
+      <p:sp>
+        <p:nvSpPr>
+          <p:cNvPr id="2" name="Slide Image Placeholder 1"/>
+          <p:cNvSpPr>
+            <a:spLocks noGrp="1" noRot="1" noChangeAspect="1"/>
+          </p:cNvSpPr>
+          <p:nvPr>
+            <p:ph type="sldImg"/>
+          </p:nvPr>
+        </p:nvSpPr>
+        <p:spPr/>
+      </p:sp>
+      <p:sp>
+        <p:nvSpPr>
+          <p:cNvPr id="3" name="Notes Placeholder 2"/>
+          <p:cNvSpPr>
+            <a:spLocks noGrp="1"/>
+          </p:cNvSpPr>
+          <p:nvPr>
+            <p:ph type="body" idx="1"/>
+          </p:nvPr>
+        </p:nvSpPr>
+        <p:spPr/>
+        <p:txBody>
+          <a:bodyPr/>
+          <a:lstStyle/>
+          <a:p>
+            <a:r>
+              <a:rPr lang="en-US" dirty="0"/>
+              <a:t/>
+            </a:r>
+            <a:endParaRPr lang="en-US" dirty="0"/>
+          </a:p>
+        </p:txBody>
+      </p:sp>
+      <p:sp>
+        <p:nvSpPr>
+          <p:cNvPr id="4" name="Slide Number Placeholder 3"/>
+          <p:cNvSpPr>
+            <a:spLocks noGrp="1"/>
+          </p:cNvSpPr>
+          <p:nvPr>
+            <p:ph type="sldNum" sz="quarter" idx="10"/>
+          </p:nvPr>
+        </p:nvSpPr>
+        <p:spPr/>
+        <p:txBody>
+          <a:bodyPr/>
+          <a:lstStyle/>
+          <a:p>
+            <a:fld id="{F7021451-1387-4CA6-816F-3879F97B5CBC}" type="slidenum">
+              <a:rPr lang="en-US"/>
+              <a:t>15</a:t>
             </a:fld>
             <a:endParaRPr lang="en-US"/>
           </a:p>
@@ -3375,7 +3465,7 @@
                 <a:ea typeface="Cambria" pitchFamily="34" charset="-122"/>
                 <a:cs typeface="Cambria" pitchFamily="34" charset="-120"/>
               </a:rPr>
-              <a:t>Camada de avaliação: 10 testes no chat</a:t>
+              <a:t>Agora pelo WhatsApp de verdade</a:t>
             </a:r>
             <a:endParaRPr lang="en-US" sz="2600" dirty="0"/>
           </a:p>
@@ -3383,14 +3473,85 @@
       </p:sp>
       <p:sp>
         <p:nvSpPr>
-          <p:cNvPr id="3" name="Text 1"/>
-          <p:cNvSpPr txBox="1"/>
-          <p:nvPr/>
-        </p:nvSpPr>
-        <p:spPr>
-          <a:xfrm>
-            <a:off x="457200" y="1097280"/>
-            <a:ext cx="2560320" cy="685800"/>
+          <p:cNvPr id="3" name="Shape 1"/>
+          <p:cNvSpPr/>
+          <p:nvPr/>
+        </p:nvSpPr>
+        <p:spPr>
+          <a:xfrm>
+            <a:off x="1164336" y="996696"/>
+            <a:ext cx="6815328" cy="2624328"/>
+          </a:xfrm>
+          <a:prstGeom prst="roundRect">
+            <a:avLst>
+              <a:gd name="adj" fmla="val 2091"/>
+            </a:avLst>
+          </a:prstGeom>
+          <a:solidFill>
+            <a:schemeClr val="bg2"/>
+          </a:solidFill>
+          <a:ln w="12700">
+            <a:solidFill>
+              <a:schemeClr val="accent5"/>
+            </a:solidFill>
+            <a:prstDash val="solid"/>
+          </a:ln>
+        </p:spPr>
+      </p:sp>
+      <p:pic>
+        <p:nvPicPr>
+          <p:cNvPr id="4" name="Image 0" descr="whatsapp.png">    </p:cNvPr>
+          <p:cNvPicPr>
+            <a:picLocks noChangeAspect="1"/>
+          </p:cNvPicPr>
+          <p:nvPr/>
+        </p:nvPicPr>
+        <p:blipFill>
+          <a:blip r:embed="rId1"/>
+          <a:stretch>
+            <a:fillRect/>
+          </a:stretch>
+        </p:blipFill>
+        <p:spPr>
+          <a:xfrm>
+            <a:off x="1219200" y="1051560"/>
+            <a:ext cx="6705600" cy="2514600"/>
+          </a:xfrm>
+          <a:prstGeom prst="rect">
+            <a:avLst/>
+          </a:prstGeom>
+        </p:spPr>
+      </p:pic>
+      <p:sp>
+        <p:nvSpPr>
+          <p:cNvPr id="5" name="marcador"/>
+          <p:cNvSpPr/>
+          <p:nvPr/>
+        </p:nvSpPr>
+        <p:spPr>
+          <a:xfrm>
+            <a:off x="457200" y="3977640"/>
+            <a:ext cx="365760" cy="365760"/>
+          </a:xfrm>
+          <a:prstGeom prst="ellipse">
+            <a:avLst/>
+          </a:prstGeom>
+          <a:solidFill>
+            <a:schemeClr val="accent4"/>
+          </a:solidFill>
+          <a:ln/>
+        </p:spPr>
+      </p:sp>
+      <p:sp>
+        <p:nvSpPr>
+          <p:cNvPr id="6" name="Text 3"/>
+          <p:cNvSpPr txBox="1"/>
+          <p:nvPr/>
+        </p:nvSpPr>
+        <p:spPr>
+          <a:xfrm>
+            <a:off x="457200" y="3977640"/>
+            <a:ext cx="365760" cy="365760"/>
           </a:xfrm>
           <a:prstGeom prst="rect">
             <a:avLst/>
@@ -3402,34 +3563,101 @@
           <a:bodyPr wrap="square" lIns="0" tIns="0" rIns="0" bIns="0" rtlCol="0" anchor="ctr"/>
           <a:lstStyle/>
           <a:p>
-            <a:pPr indent="0" marL="0">
-              <a:buNone/>
-            </a:pPr>
-            <a:r>
-              <a:rPr lang="en-US" sz="4000" b="1" dirty="0">
-                <a:solidFill>
-                  <a:schemeClr val="accent4"/>
-                </a:solidFill>
-                <a:latin typeface="Cambria" pitchFamily="34" charset="0"/>
-                <a:ea typeface="Cambria" pitchFamily="34" charset="-122"/>
-                <a:cs typeface="Cambria" pitchFamily="34" charset="-120"/>
-              </a:rPr>
-              <a:t>10/10</a:t>
-            </a:r>
-            <a:endParaRPr lang="en-US" sz="4000" dirty="0"/>
-          </a:p>
-        </p:txBody>
-      </p:sp>
-      <p:sp>
-        <p:nvSpPr>
-          <p:cNvPr id="4" name="Text 2"/>
-          <p:cNvSpPr txBox="1"/>
-          <p:nvPr/>
-        </p:nvSpPr>
-        <p:spPr>
-          <a:xfrm>
-            <a:off x="457200" y="1755648"/>
-            <a:ext cx="2560320" cy="320040"/>
+            <a:pPr algn="ctr" indent="0" marL="0">
+              <a:buNone/>
+            </a:pPr>
+            <a:r>
+              <a:rPr lang="en-US" sz="1200" b="1" dirty="0">
+                <a:solidFill>
+                  <a:schemeClr val="bg1"/>
+                </a:solidFill>
+              </a:rPr>
+              <a:t>1</a:t>
+            </a:r>
+            <a:endParaRPr lang="en-US" sz="1200" dirty="0"/>
+          </a:p>
+        </p:txBody>
+      </p:sp>
+      <p:sp>
+        <p:nvSpPr>
+          <p:cNvPr id="7" name="Text 4"/>
+          <p:cNvSpPr txBox="1"/>
+          <p:nvPr/>
+        </p:nvSpPr>
+        <p:spPr>
+          <a:xfrm>
+            <a:off x="914400" y="3886200"/>
+            <a:ext cx="2194560" cy="777240"/>
+          </a:xfrm>
+          <a:prstGeom prst="rect">
+            <a:avLst/>
+          </a:prstGeom>
+          <a:noFill/>
+          <a:ln/>
+        </p:spPr>
+        <p:txBody>
+          <a:bodyPr wrap="square" lIns="0" tIns="0" rIns="0" bIns="0" rtlCol="0" anchor="t"/>
+          <a:lstStyle/>
+          <a:p>
+            <a:pPr indent="0" marL="0">
+              <a:buNone/>
+            </a:pPr>
+            <a:r>
+              <a:rPr lang="en-US" sz="1300" b="1" dirty="0">
+                <a:solidFill>
+                  <a:schemeClr val="tx1"/>
+                </a:solidFill>
+              </a:rPr>
+              <a:t>Evolution API</a:t>
+            </a:r>
+            <a:endParaRPr lang="en-US" sz="1300" dirty="0"/>
+          </a:p>
+          <a:p>
+            <a:pPr indent="0" marL="0">
+              <a:buNone/>
+            </a:pPr>
+            <a:r>
+              <a:rPr lang="en-US" sz="1100" dirty="0">
+                <a:solidFill>
+                  <a:schemeClr val="accent6"/>
+                </a:solidFill>
+              </a:rPr>
+              <a:t>Roda no PC com Docker e liga o número pelo QR Code.</a:t>
+            </a:r>
+            <a:endParaRPr lang="en-US" sz="1300" dirty="0"/>
+          </a:p>
+        </p:txBody>
+      </p:sp>
+      <p:sp>
+        <p:nvSpPr>
+          <p:cNvPr id="8" name="marcador"/>
+          <p:cNvSpPr/>
+          <p:nvPr/>
+        </p:nvSpPr>
+        <p:spPr>
+          <a:xfrm>
+            <a:off x="3246120" y="3977640"/>
+            <a:ext cx="365760" cy="365760"/>
+          </a:xfrm>
+          <a:prstGeom prst="ellipse">
+            <a:avLst/>
+          </a:prstGeom>
+          <a:solidFill>
+            <a:schemeClr val="accent4"/>
+          </a:solidFill>
+          <a:ln/>
+        </p:spPr>
+      </p:sp>
+      <p:sp>
+        <p:nvSpPr>
+          <p:cNvPr id="9" name="Text 6"/>
+          <p:cNvSpPr txBox="1"/>
+          <p:nvPr/>
+        </p:nvSpPr>
+        <p:spPr>
+          <a:xfrm>
+            <a:off x="3246120" y="3977640"/>
+            <a:ext cx="365760" cy="365760"/>
           </a:xfrm>
           <a:prstGeom prst="rect">
             <a:avLst/>
@@ -3441,16 +3669,122 @@
           <a:bodyPr wrap="square" lIns="0" tIns="0" rIns="0" bIns="0" rtlCol="0" anchor="ctr"/>
           <a:lstStyle/>
           <a:p>
-            <a:pPr indent="0" marL="0">
-              <a:buNone/>
-            </a:pPr>
-            <a:r>
-              <a:rPr lang="en-US" sz="1200" dirty="0">
+            <a:pPr algn="ctr" indent="0" marL="0">
+              <a:buNone/>
+            </a:pPr>
+            <a:r>
+              <a:rPr lang="en-US" sz="1200" b="1" dirty="0">
+                <a:solidFill>
+                  <a:schemeClr val="bg1"/>
+                </a:solidFill>
+              </a:rPr>
+              <a:t>2</a:t>
+            </a:r>
+            <a:endParaRPr lang="en-US" sz="1200" dirty="0"/>
+          </a:p>
+        </p:txBody>
+      </p:sp>
+      <p:sp>
+        <p:nvSpPr>
+          <p:cNvPr id="10" name="Text 7"/>
+          <p:cNvSpPr txBox="1"/>
+          <p:nvPr/>
+        </p:nvSpPr>
+        <p:spPr>
+          <a:xfrm>
+            <a:off x="3703320" y="3886200"/>
+            <a:ext cx="2194560" cy="777240"/>
+          </a:xfrm>
+          <a:prstGeom prst="rect">
+            <a:avLst/>
+          </a:prstGeom>
+          <a:noFill/>
+          <a:ln/>
+        </p:spPr>
+        <p:txBody>
+          <a:bodyPr wrap="square" lIns="0" tIns="0" rIns="0" bIns="0" rtlCol="0" anchor="t"/>
+          <a:lstStyle/>
+          <a:p>
+            <a:pPr indent="0" marL="0">
+              <a:buNone/>
+            </a:pPr>
+            <a:r>
+              <a:rPr lang="en-US" sz="1300" b="1" dirty="0">
+                <a:solidFill>
+                  <a:schemeClr val="tx1"/>
+                </a:solidFill>
+              </a:rPr>
+              <a:t>Mesmo agente</a:t>
+            </a:r>
+            <a:endParaRPr lang="en-US" sz="1300" dirty="0"/>
+          </a:p>
+          <a:p>
+            <a:pPr indent="0" marL="0">
+              <a:buNone/>
+            </a:pPr>
+            <a:r>
+              <a:rPr lang="en-US" sz="1100" dirty="0">
                 <a:solidFill>
                   <a:schemeClr val="accent6"/>
                 </a:solidFill>
               </a:rPr>
-              <a:t>testes com o comportamento esperado</a:t>
+              <a:t>Mesmo prompt, base e agenda. A memória é separada por número.</a:t>
+            </a:r>
+            <a:endParaRPr lang="en-US" sz="1300" dirty="0"/>
+          </a:p>
+        </p:txBody>
+      </p:sp>
+      <p:sp>
+        <p:nvSpPr>
+          <p:cNvPr id="11" name="marcador"/>
+          <p:cNvSpPr/>
+          <p:nvPr/>
+        </p:nvSpPr>
+        <p:spPr>
+          <a:xfrm>
+            <a:off x="6035040" y="3977640"/>
+            <a:ext cx="365760" cy="365760"/>
+          </a:xfrm>
+          <a:prstGeom prst="ellipse">
+            <a:avLst/>
+          </a:prstGeom>
+          <a:solidFill>
+            <a:schemeClr val="accent4"/>
+          </a:solidFill>
+          <a:ln/>
+        </p:spPr>
+      </p:sp>
+      <p:sp>
+        <p:nvSpPr>
+          <p:cNvPr id="12" name="Text 9"/>
+          <p:cNvSpPr txBox="1"/>
+          <p:nvPr/>
+        </p:nvSpPr>
+        <p:spPr>
+          <a:xfrm>
+            <a:off x="6035040" y="3977640"/>
+            <a:ext cx="365760" cy="365760"/>
+          </a:xfrm>
+          <a:prstGeom prst="rect">
+            <a:avLst/>
+          </a:prstGeom>
+          <a:noFill/>
+          <a:ln/>
+        </p:spPr>
+        <p:txBody>
+          <a:bodyPr wrap="square" lIns="0" tIns="0" rIns="0" bIns="0" rtlCol="0" anchor="ctr"/>
+          <a:lstStyle/>
+          <a:p>
+            <a:pPr algn="ctr" indent="0" marL="0">
+              <a:buNone/>
+            </a:pPr>
+            <a:r>
+              <a:rPr lang="en-US" sz="1200" b="1" dirty="0">
+                <a:solidFill>
+                  <a:schemeClr val="bg1"/>
+                </a:solidFill>
+              </a:rPr>
+              <a:t>3</a:t>
             </a:r>
             <a:endParaRPr lang="en-US" sz="1200" dirty="0"/>
           </a:p>
@@ -3458,170 +3792,54 @@
       </p:sp>
       <p:sp>
         <p:nvSpPr>
-          <p:cNvPr id="5" name="Text 3"/>
-          <p:cNvSpPr txBox="1"/>
-          <p:nvPr/>
-        </p:nvSpPr>
-        <p:spPr>
-          <a:xfrm>
-            <a:off x="457200" y="2240280"/>
-            <a:ext cx="2560320" cy="685800"/>
-          </a:xfrm>
-          <a:prstGeom prst="rect">
-            <a:avLst/>
-          </a:prstGeom>
-          <a:noFill/>
-          <a:ln/>
-        </p:spPr>
-        <p:txBody>
-          <a:bodyPr wrap="square" lIns="0" tIns="0" rIns="0" bIns="0" rtlCol="0" anchor="ctr"/>
-          <a:lstStyle/>
-          <a:p>
-            <a:pPr indent="0" marL="0">
-              <a:buNone/>
-            </a:pPr>
-            <a:r>
-              <a:rPr lang="en-US" sz="4000" b="1" dirty="0">
-                <a:solidFill>
-                  <a:schemeClr val="accent2"/>
-                </a:solidFill>
-                <a:latin typeface="Cambria" pitchFamily="34" charset="0"/>
-                <a:ea typeface="Cambria" pitchFamily="34" charset="-122"/>
-                <a:cs typeface="Cambria" pitchFamily="34" charset="-120"/>
-              </a:rPr>
-              <a:t>3,1 s</a:t>
-            </a:r>
-            <a:endParaRPr lang="en-US" sz="4000" dirty="0"/>
-          </a:p>
-        </p:txBody>
-      </p:sp>
-      <p:sp>
-        <p:nvSpPr>
-          <p:cNvPr id="6" name="Text 4"/>
-          <p:cNvSpPr txBox="1"/>
-          <p:nvPr/>
-        </p:nvSpPr>
-        <p:spPr>
-          <a:xfrm>
-            <a:off x="457200" y="2898648"/>
-            <a:ext cx="2560320" cy="320040"/>
-          </a:xfrm>
-          <a:prstGeom prst="rect">
-            <a:avLst/>
-          </a:prstGeom>
-          <a:noFill/>
-          <a:ln/>
-        </p:spPr>
-        <p:txBody>
-          <a:bodyPr wrap="square" lIns="0" tIns="0" rIns="0" bIns="0" rtlCol="0" anchor="ctr"/>
-          <a:lstStyle/>
-          <a:p>
-            <a:pPr indent="0" marL="0">
-              <a:buNone/>
-            </a:pPr>
-            <a:r>
-              <a:rPr lang="en-US" sz="1200" dirty="0">
+          <p:cNvPr id="13" name="Text 10"/>
+          <p:cNvSpPr txBox="1"/>
+          <p:nvPr/>
+        </p:nvSpPr>
+        <p:spPr>
+          <a:xfrm>
+            <a:off x="6492240" y="3886200"/>
+            <a:ext cx="2194560" cy="777240"/>
+          </a:xfrm>
+          <a:prstGeom prst="rect">
+            <a:avLst/>
+          </a:prstGeom>
+          <a:noFill/>
+          <a:ln/>
+        </p:spPr>
+        <p:txBody>
+          <a:bodyPr wrap="square" lIns="0" tIns="0" rIns="0" bIns="0" rtlCol="0" anchor="t"/>
+          <a:lstStyle/>
+          <a:p>
+            <a:pPr indent="0" marL="0">
+              <a:buNone/>
+            </a:pPr>
+            <a:r>
+              <a:rPr lang="en-US" sz="1300" b="1" dirty="0">
+                <a:solidFill>
+                  <a:schemeClr val="tx1"/>
+                </a:solidFill>
+              </a:rPr>
+              <a:t>Testado</a:t>
+            </a:r>
+            <a:endParaRPr lang="en-US" sz="1300" dirty="0"/>
+          </a:p>
+          <a:p>
+            <a:pPr indent="0" marL="0">
+              <a:buNone/>
+            </a:pPr>
+            <a:r>
+              <a:rPr lang="en-US" sz="1100" dirty="0">
                 <a:solidFill>
                   <a:schemeClr val="accent6"/>
                 </a:solidFill>
               </a:rPr>
-              <a:t>tempo médio por resposta</a:t>
-            </a:r>
-            <a:endParaRPr lang="en-US" sz="1200" dirty="0"/>
-          </a:p>
-        </p:txBody>
-      </p:sp>
-      <p:sp>
-        <p:nvSpPr>
-          <p:cNvPr id="7" name="Text 5"/>
-          <p:cNvSpPr txBox="1"/>
-          <p:nvPr/>
-        </p:nvSpPr>
-        <p:spPr>
-          <a:xfrm>
-            <a:off x="457200" y="3383280"/>
-            <a:ext cx="2560320" cy="685800"/>
-          </a:xfrm>
-          <a:prstGeom prst="rect">
-            <a:avLst/>
-          </a:prstGeom>
-          <a:noFill/>
-          <a:ln/>
-        </p:spPr>
-        <p:txBody>
-          <a:bodyPr wrap="square" lIns="0" tIns="0" rIns="0" bIns="0" rtlCol="0" anchor="ctr"/>
-          <a:lstStyle/>
-          <a:p>
-            <a:pPr indent="0" marL="0">
-              <a:buNone/>
-            </a:pPr>
-            <a:r>
-              <a:rPr lang="en-US" sz="4000" b="1" dirty="0">
-                <a:solidFill>
-                  <a:schemeClr val="accent2"/>
-                </a:solidFill>
-                <a:latin typeface="Cambria" pitchFamily="34" charset="0"/>
-                <a:ea typeface="Cambria" pitchFamily="34" charset="-122"/>
-                <a:cs typeface="Cambria" pitchFamily="34" charset="-120"/>
-              </a:rPr>
-              <a:t>5,2 s</a:t>
-            </a:r>
-            <a:endParaRPr lang="en-US" sz="4000" dirty="0"/>
-          </a:p>
-        </p:txBody>
-      </p:sp>
-      <p:sp>
-        <p:nvSpPr>
-          <p:cNvPr id="8" name="Text 6"/>
-          <p:cNvSpPr txBox="1"/>
-          <p:nvPr/>
-        </p:nvSpPr>
-        <p:spPr>
-          <a:xfrm>
-            <a:off x="457200" y="4041648"/>
-            <a:ext cx="2560320" cy="320040"/>
-          </a:xfrm>
-          <a:prstGeom prst="rect">
-            <a:avLst/>
-          </a:prstGeom>
-          <a:noFill/>
-          <a:ln/>
-        </p:spPr>
-        <p:txBody>
-          <a:bodyPr wrap="square" lIns="0" tIns="0" rIns="0" bIns="0" rtlCol="0" anchor="ctr"/>
-          <a:lstStyle/>
-          <a:p>
-            <a:pPr indent="0" marL="0">
-              <a:buNone/>
-            </a:pPr>
-            <a:r>
-              <a:rPr lang="en-US" sz="1200" dirty="0">
-                <a:solidFill>
-                  <a:schemeClr val="accent6"/>
-                </a:solidFill>
-              </a:rPr>
-              <a:t>média quando usa a agenda</a:t>
-            </a:r>
-            <a:endParaRPr lang="en-US" sz="1200" dirty="0"/>
-          </a:p>
-        </p:txBody>
-      </p:sp>
-      <p:graphicFrame>
-        <p:nvGraphicFramePr>
-          <p:cNvPr id="9" name="Chart 0" descr=""/>
-          <p:cNvGraphicFramePr/>
-          <p:nvPr/>
-        </p:nvGraphicFramePr>
-        <p:xfrm>
-          <a:off x="3291840" y="1051560"/>
-          <a:ext cx="5394960" cy="3566160"/>
-        </p:xfrm>
-        <a:graphic xmlns:a="http://schemas.openxmlformats.org/drawingml/2006/main">
-          <a:graphicData uri="http://schemas.openxmlformats.org/drawingml/2006/chart">
-            <c:chart xmlns:c="http://schemas.openxmlformats.org/drawingml/2006/chart" r:id="rId1"/>
-          </a:graphicData>
-        </a:graphic>
-      </p:graphicFrame>
+              <a:t>11 mensagens, todas respondidas em cerca de 3 s, com evento criado na agenda.</a:t>
+            </a:r>
+            <a:endParaRPr lang="en-US" sz="1300" dirty="0"/>
+          </a:p>
+        </p:txBody>
+      </p:sp>
       <p:sp>
         <p:nvSpPr>
           <p:cNvPr id="25" name="Slide Number Placeholder 0"/>
@@ -3727,7 +3945,7 @@
                 <a:ea typeface="Cambria" pitchFamily="34" charset="-122"/>
                 <a:cs typeface="Cambria" pitchFamily="34" charset="-120"/>
               </a:rPr>
-              <a:t>Testes e refinamento: o que deu errado e como corrigi</a:t>
+              <a:t>Camada de avaliação: 10 testes no chat</a:t>
             </a:r>
             <a:endParaRPr lang="en-US" sz="2600" dirty="0"/>
           </a:p>
@@ -3735,36 +3953,14 @@
       </p:sp>
       <p:sp>
         <p:nvSpPr>
-          <p:cNvPr id="3" name="cartao"/>
-          <p:cNvSpPr/>
+          <p:cNvPr id="3" name="Text 1"/>
+          <p:cNvSpPr txBox="1"/>
           <p:nvPr/>
         </p:nvSpPr>
         <p:spPr>
           <a:xfrm>
             <a:off x="457200" y="1097280"/>
-            <a:ext cx="4023360" cy="2697480"/>
-          </a:xfrm>
-          <a:prstGeom prst="roundRect">
-            <a:avLst>
-              <a:gd name="adj" fmla="val 2712"/>
-            </a:avLst>
-          </a:prstGeom>
-          <a:solidFill>
-            <a:schemeClr val="bg2"/>
-          </a:solidFill>
-          <a:ln/>
-        </p:spPr>
-      </p:sp>
-      <p:sp>
-        <p:nvSpPr>
-          <p:cNvPr id="4" name="Text 2"/>
-          <p:cNvSpPr txBox="1"/>
-          <p:nvPr/>
-        </p:nvSpPr>
-        <p:spPr>
-          <a:xfrm>
-            <a:off x="685800" y="1234440"/>
-            <a:ext cx="3566160" cy="274320"/>
+            <a:ext cx="2560320" cy="685800"/>
           </a:xfrm>
           <a:prstGeom prst="rect">
             <a:avLst/>
@@ -3780,172 +3976,66 @@
               <a:buNone/>
             </a:pPr>
             <a:r>
-              <a:rPr lang="en-US" sz="1000" b="1" spc="200" kern="0" dirty="0">
-                <a:solidFill>
-                  <a:schemeClr val="accent3"/>
-                </a:solidFill>
-              </a:rPr>
-              <a:t>AJUSTE 1</a:t>
-            </a:r>
-            <a:endParaRPr lang="en-US" sz="1000" dirty="0"/>
-          </a:p>
-        </p:txBody>
-      </p:sp>
-      <p:sp>
-        <p:nvSpPr>
-          <p:cNvPr id="5" name="Text 3"/>
-          <p:cNvSpPr txBox="1"/>
-          <p:nvPr/>
-        </p:nvSpPr>
-        <p:spPr>
-          <a:xfrm>
-            <a:off x="685800" y="1508760"/>
-            <a:ext cx="3566160" cy="365760"/>
-          </a:xfrm>
-          <a:prstGeom prst="rect">
-            <a:avLst/>
-          </a:prstGeom>
-          <a:noFill/>
-          <a:ln/>
-        </p:spPr>
-        <p:txBody>
-          <a:bodyPr wrap="square" lIns="0" tIns="0" rIns="0" bIns="0" rtlCol="0" anchor="ctr"/>
-          <a:lstStyle/>
-          <a:p>
-            <a:pPr indent="0" marL="0">
-              <a:buNone/>
-            </a:pPr>
-            <a:r>
-              <a:rPr lang="en-US" sz="1600" b="1" dirty="0">
-                <a:solidFill>
-                  <a:schemeClr val="tx1"/>
+              <a:rPr lang="en-US" sz="4000" b="1" dirty="0">
+                <a:solidFill>
+                  <a:schemeClr val="accent4"/>
                 </a:solidFill>
                 <a:latin typeface="Cambria" pitchFamily="34" charset="0"/>
                 <a:ea typeface="Cambria" pitchFamily="34" charset="-122"/>
                 <a:cs typeface="Cambria" pitchFamily="34" charset="-120"/>
               </a:rPr>
-              <a:t>Horário sobreposto e vazamento</a:t>
-            </a:r>
-            <a:endParaRPr lang="en-US" sz="1600" dirty="0"/>
-          </a:p>
-        </p:txBody>
-      </p:sp>
-      <p:sp>
-        <p:nvSpPr>
-          <p:cNvPr id="6" name="Text 4"/>
-          <p:cNvSpPr txBox="1"/>
-          <p:nvPr/>
-        </p:nvSpPr>
-        <p:spPr>
-          <a:xfrm>
-            <a:off x="685800" y="1920240"/>
-            <a:ext cx="3566160" cy="1783080"/>
-          </a:xfrm>
-          <a:prstGeom prst="rect">
-            <a:avLst/>
-          </a:prstGeom>
-          <a:noFill/>
-          <a:ln/>
-        </p:spPr>
-        <p:txBody>
-          <a:bodyPr wrap="square" lIns="0" tIns="0" rIns="0" bIns="0" rtlCol="0" anchor="t"/>
-          <a:lstStyle/>
-          <a:p>
-            <a:pPr indent="0" marL="0">
-              <a:spcAft>
-                <a:spcPts val="800"/>
-              </a:spcAft>
-              <a:buNone/>
-            </a:pPr>
-            <a:r>
-              <a:rPr lang="en-US" sz="1200" b="1" dirty="0">
-                <a:solidFill>
-                  <a:schemeClr val="accent3"/>
-                </a:solidFill>
-              </a:rPr>
-              <a:t>Problema: </a:t>
-            </a:r>
-            <a:pPr indent="0" marL="0">
-              <a:spcAft>
-                <a:spcPts val="800"/>
-              </a:spcAft>
+              <a:t>10/10</a:t>
+            </a:r>
+            <a:endParaRPr lang="en-US" sz="4000" dirty="0"/>
+          </a:p>
+        </p:txBody>
+      </p:sp>
+      <p:sp>
+        <p:nvSpPr>
+          <p:cNvPr id="4" name="Text 2"/>
+          <p:cNvSpPr txBox="1"/>
+          <p:nvPr/>
+        </p:nvSpPr>
+        <p:spPr>
+          <a:xfrm>
+            <a:off x="457200" y="1755648"/>
+            <a:ext cx="2560320" cy="320040"/>
+          </a:xfrm>
+          <a:prstGeom prst="rect">
+            <a:avLst/>
+          </a:prstGeom>
+          <a:noFill/>
+          <a:ln/>
+        </p:spPr>
+        <p:txBody>
+          <a:bodyPr wrap="square" lIns="0" tIns="0" rIns="0" bIns="0" rtlCol="0" anchor="ctr"/>
+          <a:lstStyle/>
+          <a:p>
+            <a:pPr indent="0" marL="0">
               <a:buNone/>
             </a:pPr>
             <a:r>
               <a:rPr lang="en-US" sz="1200" dirty="0">
                 <a:solidFill>
-                  <a:schemeClr val="tx1"/>
-                </a:solidFill>
-              </a:rPr>
-              <a:t>Ofereceu coloração às 10h com a profissional ocupada das 9h às 11h, e mostrou à cliente agendamentos de outras pessoas.</a:t>
+                  <a:schemeClr val="accent6"/>
+                </a:solidFill>
+              </a:rPr>
+              <a:t>testes com o comportamento esperado</a:t>
             </a:r>
             <a:endParaRPr lang="en-US" sz="1200" dirty="0"/>
           </a:p>
-          <a:p>
-            <a:pPr indent="0" marL="0">
-              <a:spcAft>
-                <a:spcPts val="800"/>
-              </a:spcAft>
-              <a:buNone/>
-            </a:pPr>
-            <a:r>
-              <a:rPr lang="en-US" sz="1200" b="1" dirty="0">
-                <a:solidFill>
-                  <a:schemeClr val="accent4"/>
-                </a:solidFill>
-              </a:rPr>
-              <a:t>Correção: </a:t>
-            </a:r>
-            <a:pPr indent="0" marL="0">
-              <a:spcAft>
-                <a:spcPts val="800"/>
-              </a:spcAft>
-              <a:buNone/>
-            </a:pPr>
-            <a:r>
-              <a:rPr lang="en-US" sz="1200" dirty="0">
-                <a:solidFill>
-                  <a:schemeClr val="tx1"/>
-                </a:solidFill>
-              </a:rPr>
-              <a:t>Prompt com exemplo de como conferir o intervalo inteiro e regra de privacidade.</a:t>
-            </a:r>
-            <a:endParaRPr lang="en-US" sz="1200" dirty="0"/>
-          </a:p>
-        </p:txBody>
-      </p:sp>
-      <p:sp>
-        <p:nvSpPr>
-          <p:cNvPr id="7" name="cartao"/>
-          <p:cNvSpPr/>
-          <p:nvPr/>
-        </p:nvSpPr>
-        <p:spPr>
-          <a:xfrm>
-            <a:off x="4663440" y="1097280"/>
-            <a:ext cx="4023360" cy="2697480"/>
-          </a:xfrm>
-          <a:prstGeom prst="roundRect">
-            <a:avLst>
-              <a:gd name="adj" fmla="val 2712"/>
-            </a:avLst>
-          </a:prstGeom>
-          <a:solidFill>
-            <a:schemeClr val="bg2"/>
-          </a:solidFill>
-          <a:ln/>
-        </p:spPr>
-      </p:sp>
-      <p:sp>
-        <p:nvSpPr>
-          <p:cNvPr id="8" name="Text 6"/>
-          <p:cNvSpPr txBox="1"/>
-          <p:nvPr/>
-        </p:nvSpPr>
-        <p:spPr>
-          <a:xfrm>
-            <a:off x="4892040" y="1234440"/>
-            <a:ext cx="3566160" cy="274320"/>
+        </p:txBody>
+      </p:sp>
+      <p:sp>
+        <p:nvSpPr>
+          <p:cNvPr id="5" name="Text 3"/>
+          <p:cNvSpPr txBox="1"/>
+          <p:nvPr/>
+        </p:nvSpPr>
+        <p:spPr>
+          <a:xfrm>
+            <a:off x="457200" y="2240280"/>
+            <a:ext cx="2560320" cy="685800"/>
           </a:xfrm>
           <a:prstGeom prst="rect">
             <a:avLst/>
@@ -3961,187 +4051,147 @@
               <a:buNone/>
             </a:pPr>
             <a:r>
-              <a:rPr lang="en-US" sz="1000" b="1" spc="200" kern="0" dirty="0">
-                <a:solidFill>
-                  <a:schemeClr val="accent3"/>
-                </a:solidFill>
-              </a:rPr>
-              <a:t>AJUSTE 2</a:t>
-            </a:r>
-            <a:endParaRPr lang="en-US" sz="1000" dirty="0"/>
-          </a:p>
-        </p:txBody>
-      </p:sp>
-      <p:sp>
-        <p:nvSpPr>
-          <p:cNvPr id="9" name="Text 7"/>
-          <p:cNvSpPr txBox="1"/>
-          <p:nvPr/>
-        </p:nvSpPr>
-        <p:spPr>
-          <a:xfrm>
-            <a:off x="4892040" y="1508760"/>
-            <a:ext cx="3566160" cy="365760"/>
-          </a:xfrm>
-          <a:prstGeom prst="rect">
-            <a:avLst/>
-          </a:prstGeom>
-          <a:noFill/>
-          <a:ln/>
-        </p:spPr>
-        <p:txBody>
-          <a:bodyPr wrap="square" lIns="0" tIns="0" rIns="0" bIns="0" rtlCol="0" anchor="ctr"/>
-          <a:lstStyle/>
-          <a:p>
-            <a:pPr indent="0" marL="0">
-              <a:buNone/>
-            </a:pPr>
-            <a:r>
-              <a:rPr lang="en-US" sz="1600" b="1" dirty="0">
-                <a:solidFill>
-                  <a:schemeClr val="tx1"/>
+              <a:rPr lang="en-US" sz="4000" b="1" dirty="0">
+                <a:solidFill>
+                  <a:schemeClr val="accent2"/>
                 </a:solidFill>
                 <a:latin typeface="Cambria" pitchFamily="34" charset="0"/>
                 <a:ea typeface="Cambria" pitchFamily="34" charset="-122"/>
                 <a:cs typeface="Cambria" pitchFamily="34" charset="-120"/>
               </a:rPr>
-              <a:t>Alternativa com sobreposição</a:t>
-            </a:r>
-            <a:endParaRPr lang="en-US" sz="1600" dirty="0"/>
-          </a:p>
-        </p:txBody>
-      </p:sp>
-      <p:sp>
-        <p:nvSpPr>
-          <p:cNvPr id="10" name="Text 8"/>
-          <p:cNvSpPr txBox="1"/>
-          <p:nvPr/>
-        </p:nvSpPr>
-        <p:spPr>
-          <a:xfrm>
-            <a:off x="4892040" y="1920240"/>
-            <a:ext cx="3566160" cy="1783080"/>
-          </a:xfrm>
-          <a:prstGeom prst="rect">
-            <a:avLst/>
-          </a:prstGeom>
-          <a:noFill/>
-          <a:ln/>
-        </p:spPr>
-        <p:txBody>
-          <a:bodyPr wrap="square" lIns="0" tIns="0" rIns="0" bIns="0" rtlCol="0" anchor="t"/>
-          <a:lstStyle/>
-          <a:p>
-            <a:pPr indent="0" marL="0">
-              <a:spcAft>
-                <a:spcPts val="800"/>
-              </a:spcAft>
-              <a:buNone/>
-            </a:pPr>
-            <a:r>
-              <a:rPr lang="en-US" sz="1200" b="1" dirty="0">
-                <a:solidFill>
-                  <a:schemeClr val="accent3"/>
-                </a:solidFill>
-              </a:rPr>
-              <a:t>Problema: </a:t>
-            </a:r>
-            <a:pPr indent="0" marL="0">
-              <a:spcAft>
-                <a:spcPts val="800"/>
-              </a:spcAft>
+              <a:t>3,1 s</a:t>
+            </a:r>
+            <a:endParaRPr lang="en-US" sz="4000" dirty="0"/>
+          </a:p>
+        </p:txBody>
+      </p:sp>
+      <p:sp>
+        <p:nvSpPr>
+          <p:cNvPr id="6" name="Text 4"/>
+          <p:cNvSpPr txBox="1"/>
+          <p:nvPr/>
+        </p:nvSpPr>
+        <p:spPr>
+          <a:xfrm>
+            <a:off x="457200" y="2898648"/>
+            <a:ext cx="2560320" cy="320040"/>
+          </a:xfrm>
+          <a:prstGeom prst="rect">
+            <a:avLst/>
+          </a:prstGeom>
+          <a:noFill/>
+          <a:ln/>
+        </p:spPr>
+        <p:txBody>
+          <a:bodyPr wrap="square" lIns="0" tIns="0" rIns="0" bIns="0" rtlCol="0" anchor="ctr"/>
+          <a:lstStyle/>
+          <a:p>
+            <a:pPr indent="0" marL="0">
               <a:buNone/>
             </a:pPr>
             <a:r>
               <a:rPr lang="en-US" sz="1200" dirty="0">
                 <a:solidFill>
-                  <a:schemeClr val="tx1"/>
-                </a:solidFill>
-              </a:rPr>
-              <a:t>No teste 9, uma das opções (mechas às 13h) passava por cima de uma hidratação às 14h.</a:t>
+                  <a:schemeClr val="accent6"/>
+                </a:solidFill>
+              </a:rPr>
+              <a:t>tempo médio por resposta</a:t>
             </a:r>
             <a:endParaRPr lang="en-US" sz="1200" dirty="0"/>
           </a:p>
-          <a:p>
-            <a:pPr indent="0" marL="0">
-              <a:spcAft>
-                <a:spcPts val="800"/>
-              </a:spcAft>
-              <a:buNone/>
-            </a:pPr>
-            <a:r>
-              <a:rPr lang="en-US" sz="1200" b="1" dirty="0">
-                <a:solidFill>
-                  <a:schemeClr val="accent4"/>
-                </a:solidFill>
-              </a:rPr>
-              <a:t>Correção: </a:t>
-            </a:r>
-            <a:pPr indent="0" marL="0">
-              <a:spcAft>
-                <a:spcPts val="800"/>
-              </a:spcAft>
+        </p:txBody>
+      </p:sp>
+      <p:sp>
+        <p:nvSpPr>
+          <p:cNvPr id="7" name="Text 5"/>
+          <p:cNvSpPr txBox="1"/>
+          <p:nvPr/>
+        </p:nvSpPr>
+        <p:spPr>
+          <a:xfrm>
+            <a:off x="457200" y="3383280"/>
+            <a:ext cx="2560320" cy="685800"/>
+          </a:xfrm>
+          <a:prstGeom prst="rect">
+            <a:avLst/>
+          </a:prstGeom>
+          <a:noFill/>
+          <a:ln/>
+        </p:spPr>
+        <p:txBody>
+          <a:bodyPr wrap="square" lIns="0" tIns="0" rIns="0" bIns="0" rtlCol="0" anchor="ctr"/>
+          <a:lstStyle/>
+          <a:p>
+            <a:pPr indent="0" marL="0">
+              <a:buNone/>
+            </a:pPr>
+            <a:r>
+              <a:rPr lang="en-US" sz="4000" b="1" dirty="0">
+                <a:solidFill>
+                  <a:schemeClr val="accent2"/>
+                </a:solidFill>
+                <a:latin typeface="Cambria" pitchFamily="34" charset="0"/>
+                <a:ea typeface="Cambria" pitchFamily="34" charset="-122"/>
+                <a:cs typeface="Cambria" pitchFamily="34" charset="-120"/>
+              </a:rPr>
+              <a:t>5,2 s</a:t>
+            </a:r>
+            <a:endParaRPr lang="en-US" sz="4000" dirty="0"/>
+          </a:p>
+        </p:txBody>
+      </p:sp>
+      <p:sp>
+        <p:nvSpPr>
+          <p:cNvPr id="8" name="Text 6"/>
+          <p:cNvSpPr txBox="1"/>
+          <p:nvPr/>
+        </p:nvSpPr>
+        <p:spPr>
+          <a:xfrm>
+            <a:off x="457200" y="4041648"/>
+            <a:ext cx="2560320" cy="320040"/>
+          </a:xfrm>
+          <a:prstGeom prst="rect">
+            <a:avLst/>
+          </a:prstGeom>
+          <a:noFill/>
+          <a:ln/>
+        </p:spPr>
+        <p:txBody>
+          <a:bodyPr wrap="square" lIns="0" tIns="0" rIns="0" bIns="0" rtlCol="0" anchor="ctr"/>
+          <a:lstStyle/>
+          <a:p>
+            <a:pPr indent="0" marL="0">
               <a:buNone/>
             </a:pPr>
             <a:r>
               <a:rPr lang="en-US" sz="1200" dirty="0">
                 <a:solidFill>
-                  <a:schemeClr val="tx1"/>
-                </a:solidFill>
-              </a:rPr>
-              <a:t>Prompt pede para comparar cada opção, uma por uma, com os eventos do dia.</a:t>
+                  <a:schemeClr val="accent6"/>
+                </a:solidFill>
+              </a:rPr>
+              <a:t>média quando usa a agenda</a:t>
             </a:r>
             <a:endParaRPr lang="en-US" sz="1200" dirty="0"/>
           </a:p>
         </p:txBody>
       </p:sp>
-      <p:sp>
-        <p:nvSpPr>
-          <p:cNvPr id="11" name="Text 9"/>
-          <p:cNvSpPr txBox="1"/>
-          <p:nvPr/>
-        </p:nvSpPr>
-        <p:spPr>
-          <a:xfrm>
-            <a:off x="457200" y="3931920"/>
-            <a:ext cx="8229600" cy="685800"/>
-          </a:xfrm>
-          <a:prstGeom prst="rect">
-            <a:avLst/>
-          </a:prstGeom>
-          <a:noFill/>
-          <a:ln/>
-        </p:spPr>
-        <p:txBody>
-          <a:bodyPr wrap="square" lIns="0" tIns="0" rIns="0" bIns="0" rtlCol="0" anchor="t"/>
-          <a:lstStyle/>
-          <a:p>
-            <a:pPr indent="0" marL="0">
-              <a:buNone/>
-            </a:pPr>
-            <a:r>
-              <a:rPr lang="en-US" sz="1200" b="1" dirty="0">
-                <a:solidFill>
-                  <a:schemeClr val="tx2"/>
-                </a:solidFill>
-              </a:rPr>
-              <a:t>Segurança dos dados: </a:t>
-            </a:r>
-            <a:pPr indent="0" marL="0">
-              <a:buNone/>
-            </a:pPr>
-            <a:r>
-              <a:rPr lang="en-US" sz="1200" dirty="0">
-                <a:solidFill>
-                  <a:schemeClr val="tx1"/>
-                </a:solidFill>
-              </a:rPr>
-              <a:t>chaves só no gerenciador de credenciais do n8n, o agente só lê e cria eventos, pede só nome e e-mail (LGPD) e os testes usaram dados fictícios.</a:t>
-            </a:r>
-            <a:endParaRPr lang="en-US" sz="1200" dirty="0"/>
-          </a:p>
-        </p:txBody>
-      </p:sp>
+      <p:graphicFrame>
+        <p:nvGraphicFramePr>
+          <p:cNvPr id="9" name="Chart 0" descr=""/>
+          <p:cNvGraphicFramePr/>
+          <p:nvPr/>
+        </p:nvGraphicFramePr>
+        <p:xfrm>
+          <a:off x="3291840" y="1051560"/>
+          <a:ext cx="5394960" cy="3566160"/>
+        </p:xfrm>
+        <a:graphic xmlns:a="http://schemas.openxmlformats.org/drawingml/2006/main">
+          <a:graphicData uri="http://schemas.openxmlformats.org/drawingml/2006/chart">
+            <c:chart xmlns:c="http://schemas.openxmlformats.org/drawingml/2006/chart" r:id="rId1"/>
+          </a:graphicData>
+        </a:graphic>
+      </p:graphicFrame>
       <p:sp>
         <p:nvSpPr>
           <p:cNvPr id="25" name="Slide Number Placeholder 0"/>
@@ -4214,6 +4264,526 @@
       </p:grpSpPr>
       <p:sp>
         <p:nvSpPr>
+          <p:cNvPr id="2" name="Text 1"/>
+          <p:cNvSpPr/>
+          <p:nvPr>
+            <p:ph idx="101" type="title" hasCustomPrompt="1"/>
+          </p:nvPr>
+        </p:nvSpPr>
+        <p:spPr>
+          <a:xfrm>
+            <a:off x="457200" y="274320"/>
+            <a:ext cx="8229600" cy="640080"/>
+          </a:xfrm>
+          <a:prstGeom prst="rect">
+            <a:avLst/>
+          </a:prstGeom>
+          <a:noFill/>
+          <a:ln/>
+        </p:spPr>
+        <p:txBody>
+          <a:bodyPr wrap="square" lIns="0" tIns="0" rIns="0" bIns="0" rtlCol="0" anchor="ctr"/>
+          <a:lstStyle/>
+          <a:p>
+            <a:pPr algn="l" indent="0" marL="0">
+              <a:buNone/>
+            </a:pPr>
+            <a:r>
+              <a:rPr lang="en-US" sz="2600" b="1" dirty="0">
+                <a:solidFill>
+                  <a:schemeClr val="tx2"/>
+                </a:solidFill>
+                <a:latin typeface="Cambria" pitchFamily="34" charset="0"/>
+                <a:ea typeface="Cambria" pitchFamily="34" charset="-122"/>
+                <a:cs typeface="Cambria" pitchFamily="34" charset="-120"/>
+              </a:rPr>
+              <a:t>Testes e refinamento: o que deu errado e como corrigi</a:t>
+            </a:r>
+            <a:endParaRPr lang="en-US" sz="2600" dirty="0"/>
+          </a:p>
+        </p:txBody>
+      </p:sp>
+      <p:sp>
+        <p:nvSpPr>
+          <p:cNvPr id="3" name="cartao"/>
+          <p:cNvSpPr/>
+          <p:nvPr/>
+        </p:nvSpPr>
+        <p:spPr>
+          <a:xfrm>
+            <a:off x="457200" y="1097280"/>
+            <a:ext cx="4023360" cy="2697480"/>
+          </a:xfrm>
+          <a:prstGeom prst="roundRect">
+            <a:avLst>
+              <a:gd name="adj" fmla="val 2712"/>
+            </a:avLst>
+          </a:prstGeom>
+          <a:solidFill>
+            <a:schemeClr val="bg2"/>
+          </a:solidFill>
+          <a:ln/>
+        </p:spPr>
+      </p:sp>
+      <p:sp>
+        <p:nvSpPr>
+          <p:cNvPr id="4" name="Text 2"/>
+          <p:cNvSpPr txBox="1"/>
+          <p:nvPr/>
+        </p:nvSpPr>
+        <p:spPr>
+          <a:xfrm>
+            <a:off x="685800" y="1234440"/>
+            <a:ext cx="3566160" cy="274320"/>
+          </a:xfrm>
+          <a:prstGeom prst="rect">
+            <a:avLst/>
+          </a:prstGeom>
+          <a:noFill/>
+          <a:ln/>
+        </p:spPr>
+        <p:txBody>
+          <a:bodyPr wrap="square" lIns="0" tIns="0" rIns="0" bIns="0" rtlCol="0" anchor="ctr"/>
+          <a:lstStyle/>
+          <a:p>
+            <a:pPr indent="0" marL="0">
+              <a:buNone/>
+            </a:pPr>
+            <a:r>
+              <a:rPr lang="en-US" sz="1000" b="1" spc="200" kern="0" dirty="0">
+                <a:solidFill>
+                  <a:schemeClr val="accent3"/>
+                </a:solidFill>
+              </a:rPr>
+              <a:t>AJUSTE 1</a:t>
+            </a:r>
+            <a:endParaRPr lang="en-US" sz="1000" dirty="0"/>
+          </a:p>
+        </p:txBody>
+      </p:sp>
+      <p:sp>
+        <p:nvSpPr>
+          <p:cNvPr id="5" name="Text 3"/>
+          <p:cNvSpPr txBox="1"/>
+          <p:nvPr/>
+        </p:nvSpPr>
+        <p:spPr>
+          <a:xfrm>
+            <a:off x="685800" y="1508760"/>
+            <a:ext cx="3566160" cy="365760"/>
+          </a:xfrm>
+          <a:prstGeom prst="rect">
+            <a:avLst/>
+          </a:prstGeom>
+          <a:noFill/>
+          <a:ln/>
+        </p:spPr>
+        <p:txBody>
+          <a:bodyPr wrap="square" lIns="0" tIns="0" rIns="0" bIns="0" rtlCol="0" anchor="ctr"/>
+          <a:lstStyle/>
+          <a:p>
+            <a:pPr indent="0" marL="0">
+              <a:buNone/>
+            </a:pPr>
+            <a:r>
+              <a:rPr lang="en-US" sz="1600" b="1" dirty="0">
+                <a:solidFill>
+                  <a:schemeClr val="tx1"/>
+                </a:solidFill>
+                <a:latin typeface="Cambria" pitchFamily="34" charset="0"/>
+                <a:ea typeface="Cambria" pitchFamily="34" charset="-122"/>
+                <a:cs typeface="Cambria" pitchFamily="34" charset="-120"/>
+              </a:rPr>
+              <a:t>Horário sobreposto e vazamento</a:t>
+            </a:r>
+            <a:endParaRPr lang="en-US" sz="1600" dirty="0"/>
+          </a:p>
+        </p:txBody>
+      </p:sp>
+      <p:sp>
+        <p:nvSpPr>
+          <p:cNvPr id="6" name="Text 4"/>
+          <p:cNvSpPr txBox="1"/>
+          <p:nvPr/>
+        </p:nvSpPr>
+        <p:spPr>
+          <a:xfrm>
+            <a:off x="685800" y="1920240"/>
+            <a:ext cx="3566160" cy="1783080"/>
+          </a:xfrm>
+          <a:prstGeom prst="rect">
+            <a:avLst/>
+          </a:prstGeom>
+          <a:noFill/>
+          <a:ln/>
+        </p:spPr>
+        <p:txBody>
+          <a:bodyPr wrap="square" lIns="0" tIns="0" rIns="0" bIns="0" rtlCol="0" anchor="t"/>
+          <a:lstStyle/>
+          <a:p>
+            <a:pPr indent="0" marL="0">
+              <a:spcAft>
+                <a:spcPts val="800"/>
+              </a:spcAft>
+              <a:buNone/>
+            </a:pPr>
+            <a:r>
+              <a:rPr lang="en-US" sz="1200" b="1" dirty="0">
+                <a:solidFill>
+                  <a:schemeClr val="accent3"/>
+                </a:solidFill>
+              </a:rPr>
+              <a:t>Problema: </a:t>
+            </a:r>
+            <a:pPr indent="0" marL="0">
+              <a:spcAft>
+                <a:spcPts val="800"/>
+              </a:spcAft>
+              <a:buNone/>
+            </a:pPr>
+            <a:r>
+              <a:rPr lang="en-US" sz="1200" dirty="0">
+                <a:solidFill>
+                  <a:schemeClr val="tx1"/>
+                </a:solidFill>
+              </a:rPr>
+              <a:t>Ofereceu coloração às 10h com a profissional ocupada das 9h às 11h, e mostrou à cliente agendamentos de outras pessoas.</a:t>
+            </a:r>
+            <a:endParaRPr lang="en-US" sz="1200" dirty="0"/>
+          </a:p>
+          <a:p>
+            <a:pPr indent="0" marL="0">
+              <a:spcAft>
+                <a:spcPts val="800"/>
+              </a:spcAft>
+              <a:buNone/>
+            </a:pPr>
+            <a:r>
+              <a:rPr lang="en-US" sz="1200" b="1" dirty="0">
+                <a:solidFill>
+                  <a:schemeClr val="accent4"/>
+                </a:solidFill>
+              </a:rPr>
+              <a:t>Correção: </a:t>
+            </a:r>
+            <a:pPr indent="0" marL="0">
+              <a:spcAft>
+                <a:spcPts val="800"/>
+              </a:spcAft>
+              <a:buNone/>
+            </a:pPr>
+            <a:r>
+              <a:rPr lang="en-US" sz="1200" dirty="0">
+                <a:solidFill>
+                  <a:schemeClr val="tx1"/>
+                </a:solidFill>
+              </a:rPr>
+              <a:t>Prompt com exemplo de como conferir o intervalo inteiro e regra de privacidade.</a:t>
+            </a:r>
+            <a:endParaRPr lang="en-US" sz="1200" dirty="0"/>
+          </a:p>
+        </p:txBody>
+      </p:sp>
+      <p:sp>
+        <p:nvSpPr>
+          <p:cNvPr id="7" name="cartao"/>
+          <p:cNvSpPr/>
+          <p:nvPr/>
+        </p:nvSpPr>
+        <p:spPr>
+          <a:xfrm>
+            <a:off x="4663440" y="1097280"/>
+            <a:ext cx="4023360" cy="2697480"/>
+          </a:xfrm>
+          <a:prstGeom prst="roundRect">
+            <a:avLst>
+              <a:gd name="adj" fmla="val 2712"/>
+            </a:avLst>
+          </a:prstGeom>
+          <a:solidFill>
+            <a:schemeClr val="bg2"/>
+          </a:solidFill>
+          <a:ln/>
+        </p:spPr>
+      </p:sp>
+      <p:sp>
+        <p:nvSpPr>
+          <p:cNvPr id="8" name="Text 6"/>
+          <p:cNvSpPr txBox="1"/>
+          <p:nvPr/>
+        </p:nvSpPr>
+        <p:spPr>
+          <a:xfrm>
+            <a:off x="4892040" y="1234440"/>
+            <a:ext cx="3566160" cy="274320"/>
+          </a:xfrm>
+          <a:prstGeom prst="rect">
+            <a:avLst/>
+          </a:prstGeom>
+          <a:noFill/>
+          <a:ln/>
+        </p:spPr>
+        <p:txBody>
+          <a:bodyPr wrap="square" lIns="0" tIns="0" rIns="0" bIns="0" rtlCol="0" anchor="ctr"/>
+          <a:lstStyle/>
+          <a:p>
+            <a:pPr indent="0" marL="0">
+              <a:buNone/>
+            </a:pPr>
+            <a:r>
+              <a:rPr lang="en-US" sz="1000" b="1" spc="200" kern="0" dirty="0">
+                <a:solidFill>
+                  <a:schemeClr val="accent3"/>
+                </a:solidFill>
+              </a:rPr>
+              <a:t>AJUSTE 2</a:t>
+            </a:r>
+            <a:endParaRPr lang="en-US" sz="1000" dirty="0"/>
+          </a:p>
+        </p:txBody>
+      </p:sp>
+      <p:sp>
+        <p:nvSpPr>
+          <p:cNvPr id="9" name="Text 7"/>
+          <p:cNvSpPr txBox="1"/>
+          <p:nvPr/>
+        </p:nvSpPr>
+        <p:spPr>
+          <a:xfrm>
+            <a:off x="4892040" y="1508760"/>
+            <a:ext cx="3566160" cy="365760"/>
+          </a:xfrm>
+          <a:prstGeom prst="rect">
+            <a:avLst/>
+          </a:prstGeom>
+          <a:noFill/>
+          <a:ln/>
+        </p:spPr>
+        <p:txBody>
+          <a:bodyPr wrap="square" lIns="0" tIns="0" rIns="0" bIns="0" rtlCol="0" anchor="ctr"/>
+          <a:lstStyle/>
+          <a:p>
+            <a:pPr indent="0" marL="0">
+              <a:buNone/>
+            </a:pPr>
+            <a:r>
+              <a:rPr lang="en-US" sz="1600" b="1" dirty="0">
+                <a:solidFill>
+                  <a:schemeClr val="tx1"/>
+                </a:solidFill>
+                <a:latin typeface="Cambria" pitchFamily="34" charset="0"/>
+                <a:ea typeface="Cambria" pitchFamily="34" charset="-122"/>
+                <a:cs typeface="Cambria" pitchFamily="34" charset="-120"/>
+              </a:rPr>
+              <a:t>Alternativa com sobreposição</a:t>
+            </a:r>
+            <a:endParaRPr lang="en-US" sz="1600" dirty="0"/>
+          </a:p>
+        </p:txBody>
+      </p:sp>
+      <p:sp>
+        <p:nvSpPr>
+          <p:cNvPr id="10" name="Text 8"/>
+          <p:cNvSpPr txBox="1"/>
+          <p:nvPr/>
+        </p:nvSpPr>
+        <p:spPr>
+          <a:xfrm>
+            <a:off x="4892040" y="1920240"/>
+            <a:ext cx="3566160" cy="1783080"/>
+          </a:xfrm>
+          <a:prstGeom prst="rect">
+            <a:avLst/>
+          </a:prstGeom>
+          <a:noFill/>
+          <a:ln/>
+        </p:spPr>
+        <p:txBody>
+          <a:bodyPr wrap="square" lIns="0" tIns="0" rIns="0" bIns="0" rtlCol="0" anchor="t"/>
+          <a:lstStyle/>
+          <a:p>
+            <a:pPr indent="0" marL="0">
+              <a:spcAft>
+                <a:spcPts val="800"/>
+              </a:spcAft>
+              <a:buNone/>
+            </a:pPr>
+            <a:r>
+              <a:rPr lang="en-US" sz="1200" b="1" dirty="0">
+                <a:solidFill>
+                  <a:schemeClr val="accent3"/>
+                </a:solidFill>
+              </a:rPr>
+              <a:t>Problema: </a:t>
+            </a:r>
+            <a:pPr indent="0" marL="0">
+              <a:spcAft>
+                <a:spcPts val="800"/>
+              </a:spcAft>
+              <a:buNone/>
+            </a:pPr>
+            <a:r>
+              <a:rPr lang="en-US" sz="1200" dirty="0">
+                <a:solidFill>
+                  <a:schemeClr val="tx1"/>
+                </a:solidFill>
+              </a:rPr>
+              <a:t>No teste 9, uma das opções (mechas às 13h) passava por cima de uma hidratação às 14h.</a:t>
+            </a:r>
+            <a:endParaRPr lang="en-US" sz="1200" dirty="0"/>
+          </a:p>
+          <a:p>
+            <a:pPr indent="0" marL="0">
+              <a:spcAft>
+                <a:spcPts val="800"/>
+              </a:spcAft>
+              <a:buNone/>
+            </a:pPr>
+            <a:r>
+              <a:rPr lang="en-US" sz="1200" b="1" dirty="0">
+                <a:solidFill>
+                  <a:schemeClr val="accent4"/>
+                </a:solidFill>
+              </a:rPr>
+              <a:t>Correção: </a:t>
+            </a:r>
+            <a:pPr indent="0" marL="0">
+              <a:spcAft>
+                <a:spcPts val="800"/>
+              </a:spcAft>
+              <a:buNone/>
+            </a:pPr>
+            <a:r>
+              <a:rPr lang="en-US" sz="1200" dirty="0">
+                <a:solidFill>
+                  <a:schemeClr val="tx1"/>
+                </a:solidFill>
+              </a:rPr>
+              <a:t>Prompt pede para comparar cada opção, uma por uma, com os eventos do dia.</a:t>
+            </a:r>
+            <a:endParaRPr lang="en-US" sz="1200" dirty="0"/>
+          </a:p>
+        </p:txBody>
+      </p:sp>
+      <p:sp>
+        <p:nvSpPr>
+          <p:cNvPr id="11" name="Text 9"/>
+          <p:cNvSpPr txBox="1"/>
+          <p:nvPr/>
+        </p:nvSpPr>
+        <p:spPr>
+          <a:xfrm>
+            <a:off x="457200" y="3931920"/>
+            <a:ext cx="8229600" cy="685800"/>
+          </a:xfrm>
+          <a:prstGeom prst="rect">
+            <a:avLst/>
+          </a:prstGeom>
+          <a:noFill/>
+          <a:ln/>
+        </p:spPr>
+        <p:txBody>
+          <a:bodyPr wrap="square" lIns="0" tIns="0" rIns="0" bIns="0" rtlCol="0" anchor="t"/>
+          <a:lstStyle/>
+          <a:p>
+            <a:pPr indent="0" marL="0">
+              <a:buNone/>
+            </a:pPr>
+            <a:r>
+              <a:rPr lang="en-US" sz="1200" b="1" dirty="0">
+                <a:solidFill>
+                  <a:schemeClr val="tx2"/>
+                </a:solidFill>
+              </a:rPr>
+              <a:t>Segurança dos dados: </a:t>
+            </a:r>
+            <a:pPr indent="0" marL="0">
+              <a:buNone/>
+            </a:pPr>
+            <a:r>
+              <a:rPr lang="en-US" sz="1200" dirty="0">
+                <a:solidFill>
+                  <a:schemeClr val="tx1"/>
+                </a:solidFill>
+              </a:rPr>
+              <a:t>chaves só no gerenciador de credenciais do n8n, o agente só lê e cria eventos, pede só nome e e-mail (LGPD) e os testes usaram dados fictícios.</a:t>
+            </a:r>
+            <a:endParaRPr lang="en-US" sz="1200" dirty="0"/>
+          </a:p>
+        </p:txBody>
+      </p:sp>
+      <p:sp>
+        <p:nvSpPr>
+          <p:cNvPr id="25" name="Slide Number Placeholder 0"/>
+          <p:cNvSpPr>
+            <a:spLocks noGrp="1"/>
+          </p:cNvSpPr>
+          <p:nvPr>
+            <p:ph type="sldNum" sz="quarter" idx="4294967295"/>
+          </p:nvPr>
+        </p:nvSpPr>
+        <p:spPr>
+          <a:xfrm>
+            <a:off x="8229600" y="4773168"/>
+            <a:ext cx="457200" cy="274320"/>
+          </a:xfrm>
+          <a:prstGeom prst="rect">
+            <a:avLst/>
+          </a:prstGeom>
+          <a:extLst>
+            <a:ext uri="{C572A759-6A51-4108-AA02-DFA0A04FC94B}">
+              <ma14:wrappingTextBoxFlag xmlns:ma14="http://schemas.microsoft.com/office/mac/drawingml/2011/main" val="0"/>
+            </a:ext>
+          </a:extLst>
+        </p:spPr>
+        <p:txBody>
+          <a:bodyPr/>
+          <a:lstStyle>
+            <a:lvl1pPr>
+              <a:defRPr sz="900">
+                <a:solidFill>
+                  <a:schemeClr val="accent6"/>
+                </a:solidFill>
+              </a:defRPr>
+            </a:lvl1pPr>
+          </a:lstStyle>
+          <a:p>
+            <a:pPr algn="r"/>
+            <a:fld id="{F7021451-1387-4CA6-816F-3879F97B5CBC}" type="slidenum">
+              <a:rPr b="0" lang="en-US"/>
+              <a:t>14</a:t>
+            </a:fld>
+            <a:endParaRPr lang="en-US"/>
+          </a:p>
+        </p:txBody>
+      </p:sp>
+    </p:spTree>
+  </p:cSld>
+  <p:clrMapOvr>
+    <a:masterClrMapping/>
+  </p:clrMapOvr>
+</p:sld>
+</file>
+
+<file path=ppt/slides/slide15.xml><?xml version="1.0" encoding="utf-8"?>
+<p:sld xmlns:a="http://schemas.openxmlformats.org/drawingml/2006/main" xmlns:r="http://schemas.openxmlformats.org/officeDocument/2006/relationships" xmlns:p="http://schemas.openxmlformats.org/presentationml/2006/main">
+  <p:cSld name="Slide 15">
+    <p:spTree>
+      <p:nvGrpSpPr>
+        <p:cNvPr id="1" name=""/>
+        <p:cNvGrpSpPr/>
+        <p:nvPr/>
+      </p:nvGrpSpPr>
+      <p:grpSpPr>
+        <a:xfrm>
+          <a:off x="0" y="0"/>
+          <a:ext cx="0" cy="0"/>
+          <a:chOff x="0" y="0"/>
+          <a:chExt cx="0" cy="0"/>
+        </a:xfrm>
+      </p:grpSpPr>
+      <p:sp>
+        <p:nvSpPr>
           <p:cNvPr id="2" name="Text 0"/>
           <p:cNvSpPr txBox="1"/>
           <p:nvPr/>
@@ -4429,7 +4999,7 @@
                   <a:schemeClr val="bg1"/>
                 </a:solidFill>
               </a:rPr>
-              <a:t>WhatsApp real (Evolution API)</a:t>
+              <a:t>Servidor com endereço fixo</a:t>
             </a:r>
             <a:endParaRPr lang="en-US" sz="1200" dirty="0"/>
           </a:p>
@@ -6801,7 +7371,7 @@
                 <a:ea typeface="Cambria" pitchFamily="34" charset="-122"/>
                 <a:cs typeface="Cambria" pitchFamily="34" charset="-120"/>
               </a:rPr>
-              <a:t>Chat do n8n</a:t>
+              <a:t>WhatsApp</a:t>
             </a:r>
             <a:endParaRPr lang="en-US" sz="1800" dirty="0"/>
           </a:p>
@@ -6837,7 +7407,7 @@
                   <a:schemeClr val="accent6"/>
                 </a:solidFill>
               </a:rPr>
-              <a:t>Simula o WhatsApp no MVP. Depois: Evolution API.</a:t>
+              <a:t>Evolution API liga um número real ao n8n. Nos testes, o chat do n8n.</a:t>
             </a:r>
             <a:endParaRPr lang="en-US" sz="1200" dirty="0"/>
           </a:p>

</xml_diff>